<commit_message>
Refocus day 2 and 3 materials on Flutter
</commit_message>
<xml_diff>
--- a/Hari_2_Flutter_Professional.pptx
+++ b/Hari_2_Flutter_Professional.pptx
@@ -552,13 +552,13 @@
           <a:p/>
           <a:p>
             <a:r>
-              <a:t>ARAHAN TRAINER: Tunjukkan bahwa backend hosted menggantikan server kelas, tetapi kontrak endpoint tetap sama.</a:t>
+              <a:t>ARAHAN TRAINER: Tegaskan bahwa backend sudah disiapkan. Waktu kelas dipakai untuk implementasi Flutter dan pembuktian perilakunya.</a:t>
             </a:r>
           </a:p>
           <a:p/>
           <a:p>
             <a:r>
-              <a:t>PERTANYAAN DISKUSI: Apa risiko terbesar ketika UI langsung bergantung pada detail backend?</a:t>
+              <a:t>PERTANYAAN DISKUSI: Apa risiko terbesar ketika UI langsung bergantung pada detail HTTP?</a:t>
             </a:r>
           </a:p>
           <a:p/>
@@ -734,19 +734,19 @@
           <a:p/>
           <a:p>
             <a:r>
-              <a:t>TUJUAN: Membuka sesi API.</a:t>
+              <a:t>TUJUAN: Membuka sesi API Flutter.</a:t>
             </a:r>
           </a:p>
           <a:p/>
           <a:p>
             <a:r>
-              <a:t>ARAHAN TRAINER: Pastikan Swagger UI dan /health dapat diakses sebelum coding Flutter.</a:t>
+              <a:t>ARAHAN TRAINER: Endpoint dan backend sudah siap. Mulai dari response contract lalu implementasikan ApiClient.</a:t>
             </a:r>
           </a:p>
           <a:p/>
           <a:p>
             <a:r>
-              <a:t>PERTANYAAN DISKUSI: Apa yang harus disepakati sebelum endpoint diimplementasikan?</a:t>
+              <a:t>PERTANYAAN DISKUSI: Bagaimana mencegah detail HTTP bocor ke widget?</a:t>
             </a:r>
           </a:p>
           <a:p/>
@@ -828,25 +828,25 @@
           <a:p/>
           <a:p>
             <a:r>
-              <a:t>TUJUAN: Menjelaskan hubungan Flutter–backend–Swagger–Docker.</a:t>
+              <a:t>TUJUAN: Menjelaskan aliran integrasi Flutter.</a:t>
             </a:r>
           </a:p>
           <a:p/>
           <a:p>
             <a:r>
-              <a:t>ARAHAN TRAINER: Tekankan bahwa Docker adalah packaging/deployment; aplikasi Flutter hanya peduli kontrak dan base URL.</a:t>
+              <a:t>ARAHAN TRAINER: Trace aksi user sampai ApiClient dan kembali sebagai UI state. Backend/deployment cukup disebut sebagai prasyarat.</a:t>
             </a:r>
           </a:p>
           <a:p/>
           <a:p>
             <a:r>
-              <a:t>PERTANYAAN DISKUSI: Bagian mana yang berubah ketika backend dipindah host?</a:t>
+              <a:t>PERTANYAAN DISKUSI: Layer mana yang memutuskan cache fallback?</a:t>
             </a:r>
           </a:p>
           <a:p/>
           <a:p>
             <a:r>
-              <a:t>RUJUKAN: Modul Hari 2; handoff API hosted.</a:t>
+              <a:t>RUJUKAN: Modul Hari 2: data flow.</a:t>
             </a:r>
           </a:p>
         </p:txBody>
@@ -922,25 +922,25 @@
           <a:p/>
           <a:p>
             <a:r>
-              <a:t>TUJUAN: Mengajarkan cara membaca Swagger secara engineering.</a:t>
+              <a:t>TUJUAN: Mengajarkan cara menerjemahkan kontrak ke Dart.</a:t>
             </a:r>
           </a:p>
           <a:p/>
           <a:p>
             <a:r>
-              <a:t>ARAHAN TRAINER: Buka login, list, create. Cocokkan example dengan model Dart dan validator.</a:t>
+              <a:t>ARAHAN TRAINER: Cocokkan login, list, dan create dengan model, enum, validator, serta failure mapper.</a:t>
             </a:r>
           </a:p>
           <a:p/>
           <a:p>
             <a:r>
-              <a:t>PERTANYAAN DISKUSI: Apa yang harus terjadi bila Swagger dan respons nyata berbeda?</a:t>
+              <a:t>PERTANYAAN DISKUSI: Apa yang terjadi bila field wajib hilang?</a:t>
             </a:r>
           </a:p>
           <a:p/>
           <a:p>
             <a:r>
-              <a:t>RUJUKAN: OpenAPI contract backend training.</a:t>
+              <a:t>RUJUKAN: Kontrak API training dan model Dart.</a:t>
             </a:r>
           </a:p>
         </p:txBody>
@@ -1016,19 +1016,19 @@
           <a:p/>
           <a:p>
             <a:r>
-              <a:t>TUJUAN: Menyepakati kontrak endpoint.</a:t>
+              <a:t>TUJUAN: Memetakan endpoint ke method Flutter.</a:t>
             </a:r>
           </a:p>
           <a:p/>
           <a:p>
             <a:r>
-              <a:t>ARAHAN TRAINER: Jalankan satu request per endpoint dari Swagger UI sebelum Flutter.</a:t>
+              <a:t>ARAHAN TRAINER: Jalankan satu request contoh, lalu implementasikan method dan model yang sesuai.</a:t>
             </a:r>
           </a:p>
           <a:p/>
           <a:p>
             <a:r>
-              <a:t>PERTANYAAN DISKUSI: Mengapa /health dan versi image berguna saat troubleshooting?</a:t>
+              <a:t>PERTANYAAN DISKUSI: Status mana yang mengakhiri session?</a:t>
             </a:r>
           </a:p>
           <a:p/>
@@ -1680,7 +1680,7 @@
           <a:p/>
           <a:p>
             <a:r>
-              <a:t>ARAHAN TRAINER: Peserta bekerja berpasangan. Reviewer memeriksa status dan schema.</a:t>
+              <a:t>ARAHAN TRAINER: Peserta bekerja berpasangan. Reviewer memeriksa ApiClient, mapping, status dan UI state.</a:t>
             </a:r>
           </a:p>
           <a:p/>
@@ -1692,7 +1692,7 @@
           <a:p/>
           <a:p>
             <a:r>
-              <a:t>RUJUKAN: requests.http dan Swagger API training.</a:t>
+              <a:t>RUJUKAN: requests.http dan kontrak API training.</a:t>
             </a:r>
           </a:p>
         </p:txBody>
@@ -2802,13 +2802,13 @@
           <a:p/>
           <a:p>
             <a:r>
-              <a:t>TUJUAN: Menetapkan logging yang aman dan berguna.</a:t>
+              <a:t>TUJUAN: Menetapkan logging Flutter yang aman dan berguna.</a:t>
             </a:r>
           </a:p>
           <a:p/>
           <a:p>
             <a:r>
-              <a:t>ARAHAN TRAINER: Tunjukkan contoh request ID di Swagger/Express bila tersedia.</a:t>
+              <a:t>ARAHAN TRAINER: Tunjukkan method, path, status, duration, dan request ID tanpa Authorization/body sensitif.</a:t>
             </a:r>
           </a:p>
           <a:p/>
@@ -3272,25 +3272,25 @@
           <a:p/>
           <a:p>
             <a:r>
-              <a:t>TUJUAN: Menyepakati handoff API hosted.</a:t>
+              <a:t>TUJUAN: Melakukan review integrasi Flutter.</a:t>
             </a:r>
           </a:p>
           <a:p/>
           <a:p>
             <a:r>
-              <a:t>ARAHAN TRAINER: Isi placeholder URL/version bersama PIC backend sebelum kelas.</a:t>
+              <a:t>ARAHAN TRAINER: Gunakan checklist untuk source review dan demo. Detail deployment backend tidak dibahas.</a:t>
             </a:r>
           </a:p>
           <a:p/>
           <a:p>
             <a:r>
-              <a:t>PERTANYAAN DISKUSI: Siapa pemilik contract drift?</a:t>
+              <a:t>PERTANYAAN DISKUSI: Boundary mana masih bocor?</a:t>
             </a:r>
           </a:p>
           <a:p/>
           <a:p>
             <a:r>
-              <a:t>RUJUKAN: Dokumen handoff API training.</a:t>
+              <a:t>RUJUKAN: Modul dan PRD Hari 2.</a:t>
             </a:r>
           </a:p>
         </p:txBody>
@@ -7413,7 +7413,7 @@
                 </a:solidFill>
                 <a:latin typeface="Aptos"/>
               </a:rPr>
-              <a:t>Integrasi contract-first dengan Express, Swagger/OpenAPI, Docker, state, session, dan cache.</a:t>
+              <a:t>Clean architecture, REST API client, state, session, cache, dan failure handling di Flutter.</a:t>
             </a:r>
           </a:p>
         </p:txBody>
@@ -9837,7 +9837,7 @@
                 </a:solidFill>
                 <a:latin typeface="Aptos Display"/>
               </a:rPr>
-              <a:t>Contract-first API</a:t>
+              <a:t>REST API di Flutter</a:t>
             </a:r>
           </a:p>
         </p:txBody>
@@ -9876,7 +9876,7 @@
                 </a:solidFill>
                 <a:latin typeface="Aptos"/>
               </a:rPr>
-              <a:t>Swagger/OpenAPI menyamakan ekspektasi Flutter dan Express sebelum wiring UI.</a:t>
+              <a:t>Flutter membaca kontrak, memetakan JSON, dan mengubah response menjadi state yang dapat diuji.</a:t>
             </a:r>
           </a:p>
         </p:txBody>
@@ -10081,7 +10081,7 @@
                 </a:solidFill>
                 <a:latin typeface="Aptos"/>
               </a:rPr>
-              <a:t>Membaca contract</a:t>
+              <a:t>Membuat API client</a:t>
             </a:r>
           </a:p>
         </p:txBody>
@@ -10513,7 +10513,7 @@
                 </a:solidFill>
                 <a:latin typeface="Aptos"/>
               </a:rPr>
-              <a:t>API CONTRACT</a:t>
+              <a:t>API CLIENT</a:t>
             </a:r>
           </a:p>
         </p:txBody>
@@ -10552,7 +10552,7 @@
                 </a:solidFill>
                 <a:latin typeface="Aptos Display"/>
               </a:rPr>
-              <a:t>Topologi training: hosted + fallback</a:t>
+              <a:t>Aliran integrasi API dari sisi Flutter</a:t>
             </a:r>
           </a:p>
         </p:txBody>
@@ -10753,7 +10753,7 @@
                 </a:solidFill>
                 <a:latin typeface="Aptos"/>
               </a:rPr>
-              <a:t>Flutter</a:t>
+              <a:t>View</a:t>
             </a:r>
           </a:p>
         </p:txBody>
@@ -10792,8 +10792,8 @@
                 </a:solidFill>
                 <a:latin typeface="Aptos"/>
               </a:rPr>
-              <a:t>dart-define
-API_BASE_URL</a:t>
+              <a:t>render state
+user intent</a:t>
             </a:r>
           </a:p>
         </p:txBody>
@@ -10912,7 +10912,7 @@
                 </a:solidFill>
                 <a:latin typeface="Aptos"/>
               </a:rPr>
-              <a:t>HTTPS</a:t>
+              <a:t>Controller</a:t>
             </a:r>
           </a:p>
         </p:txBody>
@@ -10951,8 +10951,8 @@
                 </a:solidFill>
                 <a:latin typeface="Aptos"/>
               </a:rPr>
-              <a:t>Bearer + JSON
-X-Request-Id</a:t>
+              <a:t>orchestrate
+notify UI</a:t>
             </a:r>
           </a:p>
         </p:txBody>
@@ -11071,7 +11071,7 @@
                 </a:solidFill>
                 <a:latin typeface="Aptos"/>
               </a:rPr>
-              <a:t>Docker</a:t>
+              <a:t>Repository</a:t>
             </a:r>
           </a:p>
         </p:txBody>
@@ -11110,8 +11110,8 @@
                 </a:solidFill>
                 <a:latin typeface="Aptos"/>
               </a:rPr>
-              <a:t>Express API
-validated input</a:t>
+              <a:t>remote/cache
+policy</a:t>
             </a:r>
           </a:p>
         </p:txBody>
@@ -11230,7 +11230,7 @@
                 </a:solidFill>
                 <a:latin typeface="Aptos"/>
               </a:rPr>
-              <a:t>Data</a:t>
+              <a:t>ApiClient</a:t>
             </a:r>
           </a:p>
         </p:txBody>
@@ -11269,8 +11269,8 @@
                 </a:solidFill>
                 <a:latin typeface="Aptos"/>
               </a:rPr>
-              <a:t>DB / memory
-training data</a:t>
+              <a:t>Bearer + JSON
+timeout</a:t>
             </a:r>
           </a:p>
         </p:txBody>
@@ -11389,7 +11389,7 @@
                 </a:solidFill>
                 <a:latin typeface="Aptos"/>
               </a:rPr>
-              <a:t>Swagger</a:t>
+              <a:t>HTTPS API</a:t>
             </a:r>
           </a:p>
         </p:txBody>
@@ -11428,8 +11428,8 @@
                 </a:solidFill>
                 <a:latin typeface="Aptos"/>
               </a:rPr>
-              <a:t>/docs
-/openapi.json</a:t>
+              <a:t>contract ready
+training data</a:t>
             </a:r>
           </a:p>
         </p:txBody>
@@ -11638,7 +11638,7 @@
                 </a:solidFill>
                 <a:latin typeface="Aptos"/>
               </a:rPr>
-              <a:t>Jalur utama kelas</a:t>
+              <a:t>Fokus peserta Flutter</a:t>
             </a:r>
           </a:p>
         </p:txBody>
@@ -11680,7 +11680,7 @@
               <a:rPr>
                 <a:latin typeface="Aptos"/>
               </a:rPr>
-              <a:t>•  Hosted Express melalui HTTPS</a:t>
+              <a:t>•  Mapping JSON ke model</a:t>
             </a:r>
           </a:p>
           <a:p>
@@ -11699,7 +11699,7 @@
               <a:rPr>
                 <a:latin typeface="Aptos"/>
               </a:rPr>
-              <a:t>•  Swagger UI untuk eksplorasi</a:t>
+              <a:t>•  State dan recovery UI</a:t>
             </a:r>
           </a:p>
           <a:p>
@@ -11718,7 +11718,7 @@
               <a:rPr>
                 <a:latin typeface="Aptos"/>
               </a:rPr>
-              <a:t>•  Image Docker berversi</a:t>
+              <a:t>•  Lifecycle serta testability</a:t>
             </a:r>
           </a:p>
         </p:txBody>
@@ -11927,7 +11927,7 @@
                 </a:solidFill>
                 <a:latin typeface="Aptos"/>
               </a:rPr>
-              <a:t>Fallback operasional</a:t>
+              <a:t>Sudah disiapkan trainer</a:t>
             </a:r>
           </a:p>
         </p:txBody>
@@ -11969,7 +11969,7 @@
               <a:rPr>
                 <a:latin typeface="Aptos"/>
               </a:rPr>
-              <a:t>•  Mock Python lokal tetap tersedia</a:t>
+              <a:t>•  Base URL dan akun dummy</a:t>
             </a:r>
           </a:p>
           <a:p>
@@ -11988,7 +11988,7 @@
               <a:rPr>
                 <a:latin typeface="Aptos"/>
               </a:rPr>
-              <a:t>•  Schema dan status harus sama</a:t>
+              <a:t>•  Kontrak/status response</a:t>
             </a:r>
           </a:p>
           <a:p>
@@ -12007,7 +12007,7 @@
               <a:rPr>
                 <a:latin typeface="Aptos"/>
               </a:rPr>
-              <a:t>•  Dipakai jika jaringan/hosting bermasalah</a:t>
+              <a:t>•  Backend serta deployment</a:t>
             </a:r>
           </a:p>
         </p:txBody>
@@ -12158,7 +12158,7 @@
                 </a:solidFill>
                 <a:latin typeface="Aptos"/>
               </a:rPr>
-              <a:t>API CONTRACT</a:t>
+              <a:t>API CLIENT</a:t>
             </a:r>
           </a:p>
         </p:txBody>
@@ -12197,7 +12197,7 @@
                 </a:solidFill>
                 <a:latin typeface="Aptos Display"/>
               </a:rPr>
-              <a:t>Swagger sebagai Definition of Contract</a:t>
+              <a:t>Membaca kontrak sebagai Flutter developer</a:t>
             </a:r>
           </a:p>
         </p:txBody>
@@ -13138,7 +13138,7 @@
                 </a:solidFill>
                 <a:latin typeface="Aptos"/>
               </a:rPr>
-              <a:t>QA</a:t>
+              <a:t>FM</a:t>
             </a:r>
           </a:p>
         </p:txBody>
@@ -13177,7 +13177,7 @@
                 </a:solidFill>
                 <a:latin typeface="Aptos"/>
               </a:rPr>
-              <a:t>Quality</a:t>
+              <a:t>Flutter mapping</a:t>
             </a:r>
           </a:p>
         </p:txBody>
@@ -13219,7 +13219,7 @@
               <a:rPr>
                 <a:latin typeface="Aptos"/>
               </a:rPr>
-              <a:t>•  operationId stabil</a:t>
+              <a:t>•  DTO/model bertipe</a:t>
             </a:r>
           </a:p>
           <a:p>
@@ -13238,7 +13238,7 @@
               <a:rPr>
                 <a:latin typeface="Aptos"/>
               </a:rPr>
-              <a:t>•  Example dapat dieksekusi</a:t>
+              <a:t>•  Enum tervalidasi</a:t>
             </a:r>
           </a:p>
           <a:p>
@@ -13257,7 +13257,7 @@
               <a:rPr>
                 <a:latin typeface="Aptos"/>
               </a:rPr>
-              <a:t>•  422 punya field errors</a:t>
+              <a:t>•  422 ke field errors</a:t>
             </a:r>
           </a:p>
           <a:p>
@@ -13276,7 +13276,7 @@
               <a:rPr>
                 <a:latin typeface="Aptos"/>
               </a:rPr>
-              <a:t>•  401 konsisten</a:t>
+              <a:t>•  401 ke session flow</a:t>
             </a:r>
           </a:p>
           <a:p>
@@ -13295,7 +13295,7 @@
               <a:rPr>
                 <a:latin typeface="Aptos"/>
               </a:rPr>
-              <a:t>•  OpenAPI versioned</a:t>
+              <a:t>•  DateTime ke UTC</a:t>
             </a:r>
           </a:p>
         </p:txBody>
@@ -13670,7 +13670,7 @@
                 <a:gridCol w="2523744"/>
                 <a:gridCol w="2953512"/>
               </a:tblGrid>
-              <a:tr h="704088">
+              <a:tr h="844905">
                 <a:tc>
                   <a:txBody>
                     <a:bodyPr/>
@@ -13768,7 +13768,7 @@
                   </a:tcPr>
                 </a:tc>
               </a:tr>
-              <a:tr h="704088">
+              <a:tr h="844905">
                 <a:tc>
                   <a:txBody>
                     <a:bodyPr/>
@@ -13866,7 +13866,7 @@
                   </a:tcPr>
                 </a:tc>
               </a:tr>
-              <a:tr h="704088">
+              <a:tr h="844905">
                 <a:tc>
                   <a:txBody>
                     <a:bodyPr/>
@@ -13964,7 +13964,7 @@
                   </a:tcPr>
                 </a:tc>
               </a:tr>
-              <a:tr h="704088">
+              <a:tr h="844905">
                 <a:tc>
                   <a:txBody>
                     <a:bodyPr/>
@@ -14062,7 +14062,7 @@
                   </a:tcPr>
                 </a:tc>
               </a:tr>
-              <a:tr h="704088">
+              <a:tr h="844908">
                 <a:tc>
                   <a:txBody>
                     <a:bodyPr/>
@@ -14160,104 +14160,6 @@
                   </a:tcPr>
                 </a:tc>
               </a:tr>
-              <a:tr h="704088">
-                <a:tc>
-                  <a:txBody>
-                    <a:bodyPr/>
-                    <a:lstStyle/>
-                    <a:p>
-                      <a:pPr>
-                        <a:defRPr sz="1100">
-                          <a:solidFill>
-                            <a:srgbClr val="10233E"/>
-                          </a:solidFill>
-                          <a:latin typeface="Aptos"/>
-                        </a:defRPr>
-                      </a:pPr>
-                      <a:r>
-                        <a:t>GET /openapi.json</a:t>
-                      </a:r>
-                    </a:p>
-                  </a:txBody>
-                  <a:tcPr marL="91440" marR="91440" marT="54864" marB="54864">
-                    <a:solidFill>
-                      <a:srgbClr val="FFFFFF"/>
-                    </a:solidFill>
-                  </a:tcPr>
-                </a:tc>
-                <a:tc>
-                  <a:txBody>
-                    <a:bodyPr/>
-                    <a:lstStyle/>
-                    <a:p>
-                      <a:pPr>
-                        <a:defRPr sz="1100">
-                          <a:solidFill>
-                            <a:srgbClr val="10233E"/>
-                          </a:solidFill>
-                          <a:latin typeface="Aptos"/>
-                        </a:defRPr>
-                      </a:pPr>
-                      <a:r>
-                        <a:t>—</a:t>
-                      </a:r>
-                    </a:p>
-                  </a:txBody>
-                  <a:tcPr marL="91440" marR="91440" marT="54864" marB="54864">
-                    <a:solidFill>
-                      <a:srgbClr val="FFFFFF"/>
-                    </a:solidFill>
-                  </a:tcPr>
-                </a:tc>
-                <a:tc>
-                  <a:txBody>
-                    <a:bodyPr/>
-                    <a:lstStyle/>
-                    <a:p>
-                      <a:pPr>
-                        <a:defRPr sz="1100">
-                          <a:solidFill>
-                            <a:srgbClr val="10233E"/>
-                          </a:solidFill>
-                          <a:latin typeface="Aptos"/>
-                        </a:defRPr>
-                      </a:pPr>
-                      <a:r>
-                        <a:t>200 OpenAPI</a:t>
-                      </a:r>
-                    </a:p>
-                  </a:txBody>
-                  <a:tcPr marL="91440" marR="91440" marT="54864" marB="54864">
-                    <a:solidFill>
-                      <a:srgbClr val="FFFFFF"/>
-                    </a:solidFill>
-                  </a:tcPr>
-                </a:tc>
-                <a:tc>
-                  <a:txBody>
-                    <a:bodyPr/>
-                    <a:lstStyle/>
-                    <a:p>
-                      <a:pPr>
-                        <a:defRPr sz="1100">
-                          <a:solidFill>
-                            <a:srgbClr val="10233E"/>
-                          </a:solidFill>
-                          <a:latin typeface="Aptos"/>
-                        </a:defRPr>
-                      </a:pPr>
-                      <a:r>
-                        <a:t>—</a:t>
-                      </a:r>
-                    </a:p>
-                  </a:txBody>
-                  <a:tcPr marL="91440" marR="91440" marT="54864" marB="54864">
-                    <a:solidFill>
-                      <a:srgbClr val="FFFFFF"/>
-                    </a:solidFill>
-                  </a:tcPr>
-                </a:tc>
-              </a:tr>
             </a:tbl>
           </a:graphicData>
         </a:graphic>
@@ -14277,11 +14179,11 @@
             <a:avLst/>
           </a:prstGeom>
           <a:solidFill>
-            <a:srgbClr val="FFFFFF"/>
+            <a:srgbClr val="E4F7FB"/>
           </a:solidFill>
           <a:ln w="12700">
             <a:solidFill>
-              <a:srgbClr val="D5E1EC"/>
+              <a:srgbClr val="16C6E7"/>
             </a:solidFill>
           </a:ln>
         </p:spPr>
@@ -14309,100 +14211,14 @@
       </p:sp>
       <p:sp>
         <p:nvSpPr>
-          <p:cNvPr id="11" name="Rectangle 10"/>
-          <p:cNvSpPr/>
-          <p:nvPr/>
-        </p:nvSpPr>
-        <p:spPr>
-          <a:xfrm>
-            <a:off x="530352" y="5577840"/>
-            <a:ext cx="73152" cy="585216"/>
-          </a:xfrm>
-          <a:prstGeom prst="rect">
-            <a:avLst/>
-          </a:prstGeom>
-          <a:solidFill>
-            <a:srgbClr val="16C6E7"/>
-          </a:solidFill>
-          <a:ln>
-            <a:noFill/>
-          </a:ln>
-        </p:spPr>
-        <p:style>
-          <a:lnRef idx="1">
-            <a:schemeClr val="accent1"/>
-          </a:lnRef>
-          <a:fillRef idx="3">
-            <a:schemeClr val="accent1"/>
-          </a:fillRef>
-          <a:effectRef idx="2">
-            <a:schemeClr val="accent1"/>
-          </a:effectRef>
-          <a:fontRef idx="minor">
-            <a:schemeClr val="lt1"/>
-          </a:fontRef>
-        </p:style>
-        <p:txBody>
-          <a:bodyPr rtlCol="0" anchor="ctr"/>
-          <a:lstStyle/>
-          <a:p>
-            <a:pPr algn="ctr"/>
-          </a:p>
-        </p:txBody>
-      </p:sp>
-      <p:sp>
-        <p:nvSpPr>
-          <p:cNvPr id="12" name="Oval 11"/>
-          <p:cNvSpPr/>
-          <p:nvPr/>
-        </p:nvSpPr>
-        <p:spPr>
-          <a:xfrm>
-            <a:off x="786384" y="5779008"/>
-            <a:ext cx="384048" cy="384048"/>
-          </a:xfrm>
-          <a:prstGeom prst="ellipse">
-            <a:avLst/>
-          </a:prstGeom>
-          <a:solidFill>
-            <a:srgbClr val="16C6E7"/>
-          </a:solidFill>
-          <a:ln>
-            <a:noFill/>
-          </a:ln>
-        </p:spPr>
-        <p:style>
-          <a:lnRef idx="1">
-            <a:schemeClr val="accent1"/>
-          </a:lnRef>
-          <a:fillRef idx="3">
-            <a:schemeClr val="accent1"/>
-          </a:fillRef>
-          <a:effectRef idx="2">
-            <a:schemeClr val="accent1"/>
-          </a:effectRef>
-          <a:fontRef idx="minor">
-            <a:schemeClr val="lt1"/>
-          </a:fontRef>
-        </p:style>
-        <p:txBody>
-          <a:bodyPr rtlCol="0" anchor="ctr"/>
-          <a:lstStyle/>
-          <a:p>
-            <a:pPr algn="ctr"/>
-          </a:p>
-        </p:txBody>
-      </p:sp>
-      <p:sp>
-        <p:nvSpPr>
-          <p:cNvPr id="13" name="TextBox 12"/>
+          <p:cNvPr id="11" name="TextBox 10"/>
           <p:cNvSpPr txBox="1"/>
           <p:nvPr/>
         </p:nvSpPr>
         <p:spPr>
           <a:xfrm>
-            <a:off x="786384" y="5852160"/>
-            <a:ext cx="384048" cy="164592"/>
+            <a:off x="822960" y="5751576"/>
+            <a:ext cx="10533888" cy="228600"/>
           </a:xfrm>
           <a:prstGeom prst="rect">
             <a:avLst/>
@@ -14415,97 +14231,23 @@
           </a:bodyPr>
           <a:lstStyle/>
           <a:p>
-            <a:pPr algn="ctr">
-              <a:spcAft>
-                <a:spcPts val="0"/>
-              </a:spcAft>
-            </a:pPr>
-            <a:r>
-              <a:rPr sz="1100" b="1">
-                <a:solidFill>
-                  <a:srgbClr val="071D3B"/>
-                </a:solidFill>
-                <a:latin typeface="Aptos"/>
-              </a:rPr>
-              <a:t>v1</a:t>
-            </a:r>
-          </a:p>
-        </p:txBody>
-      </p:sp>
-      <p:sp>
-        <p:nvSpPr>
-          <p:cNvPr id="14" name="TextBox 13"/>
-          <p:cNvSpPr txBox="1"/>
-          <p:nvPr/>
-        </p:nvSpPr>
-        <p:spPr>
-          <a:xfrm>
-            <a:off x="1298448" y="5779008"/>
-            <a:ext cx="10204704" cy="320040"/>
-          </a:xfrm>
-          <a:prstGeom prst="rect">
-            <a:avLst/>
-          </a:prstGeom>
-          <a:noFill/>
-        </p:spPr>
-        <p:txBody>
-          <a:bodyPr wrap="none" lIns="0" rIns="0" tIns="0" bIns="0" anchor="t">
-            <a:spAutoFit/>
-          </a:bodyPr>
-          <a:lstStyle/>
-          <a:p>
-            <a:pPr algn="l">
-              <a:spcAft>
-                <a:spcPts val="0"/>
-              </a:spcAft>
-            </a:pPr>
-            <a:r>
-              <a:rPr sz="1600" b="1">
+            <a:r>
+              <a:rPr sz="1200" b="1">
+                <a:solidFill>
+                  <a:srgbClr val="0E5AA7"/>
+                </a:solidFill>
+                <a:latin typeface="Aptos"/>
+              </a:rPr>
+              <a:t>COMPATIBILITY  •  </a:t>
+            </a:r>
+            <a:r>
+              <a:rPr sz="1200" b="0">
                 <a:solidFill>
                   <a:srgbClr val="10233E"/>
                 </a:solidFill>
                 <a:latin typeface="Aptos"/>
               </a:rPr>
-              <a:t>Compatibility note</a:t>
-            </a:r>
-          </a:p>
-        </p:txBody>
-      </p:sp>
-      <p:sp>
-        <p:nvSpPr>
-          <p:cNvPr id="15" name="TextBox 14"/>
-          <p:cNvSpPr txBox="1"/>
-          <p:nvPr/>
-        </p:nvSpPr>
-        <p:spPr>
-          <a:xfrm>
-            <a:off x="786384" y="6281928"/>
-            <a:ext cx="10643616" cy="-283464"/>
-          </a:xfrm>
-          <a:prstGeom prst="rect">
-            <a:avLst/>
-          </a:prstGeom>
-          <a:noFill/>
-        </p:spPr>
-        <p:txBody>
-          <a:bodyPr wrap="none" lIns="0" rIns="0" tIns="0" bIns="0" anchor="t">
-            <a:spAutoFit/>
-          </a:bodyPr>
-          <a:lstStyle/>
-          <a:p>
-            <a:pPr algn="l">
-              <a:spcAft>
-                <a:spcPts val="0"/>
-              </a:spcAft>
-            </a:pPr>
-            <a:r>
-              <a:rPr sz="1200" b="0">
-                <a:solidFill>
-                  <a:srgbClr val="5D6D82"/>
-                </a:solidFill>
-                <a:latin typeface="Aptos"/>
-              </a:rPr>
-              <a:t>Backend boleh berkembang; field wajib dan status yang dipakai app tidak berubah tanpa versioning/migration.</a:t>
+              <a:t>Field wajib dan status yang dipakai app tidak berubah tanpa versioning atau migration.</a:t>
             </a:r>
           </a:p>
         </p:txBody>
@@ -21652,7 +21394,7 @@
                 </a:solidFill>
                 <a:latin typeface="Aptos"/>
               </a:rPr>
-              <a:t>Kontrak API jelas</a:t>
+              <a:t>API client bertipe</a:t>
             </a:r>
           </a:p>
         </p:txBody>
@@ -21694,7 +21436,7 @@
               <a:rPr>
                 <a:latin typeface="Aptos"/>
               </a:rPr>
-              <a:t>•  Swagger menjadi sumber kebenaran</a:t>
+              <a:t>•  Model sesuai kontrak</a:t>
             </a:r>
           </a:p>
           <a:p>
@@ -35063,7 +34805,7 @@
                 </a:solidFill>
                 <a:latin typeface="Aptos"/>
               </a:rPr>
-              <a:t>OpenAPI, auth, GET &amp; POST</a:t>
+              <a:t>API client, auth, GET &amp; POST</a:t>
             </a:r>
           </a:p>
         </p:txBody>
@@ -35147,7 +34889,7 @@
                 </a:solidFill>
                 <a:latin typeface="Aptos"/>
               </a:rPr>
-              <a:t>Kontrak lolos di Swagger dan Flutter</a:t>
+              <a:t>Data API tampil dan create berhasil</a:t>
             </a:r>
           </a:p>
         </p:txBody>
@@ -38293,7 +38035,7 @@
               <a:rPr>
                 <a:latin typeface="Aptos"/>
               </a:rPr>
-              <a:t>•  client → Express log</a:t>
+              <a:t>•  request → response</a:t>
             </a:r>
           </a:p>
           <a:p>
@@ -38312,7 +38054,7 @@
               <a:rPr>
                 <a:latin typeface="Aptos"/>
               </a:rPr>
-              <a:t>•  Docker image version</a:t>
+              <a:t>•  app version</a:t>
             </a:r>
           </a:p>
           <a:p>
@@ -40447,7 +40189,7 @@
                 </a:solidFill>
                 <a:latin typeface="Aptos"/>
               </a:rPr>
-              <a:t>Contract</a:t>
+              <a:t>API client</a:t>
             </a:r>
           </a:p>
         </p:txBody>
@@ -40489,7 +40231,7 @@
               <a:rPr>
                 <a:latin typeface="Aptos"/>
               </a:rPr>
-              <a:t>•  Swagger example</a:t>
+              <a:t>•  JSON fixture</a:t>
             </a:r>
           </a:p>
           <a:p>
@@ -40546,7 +40288,7 @@
               <a:rPr>
                 <a:latin typeface="Aptos"/>
               </a:rPr>
-              <a:t>•  hosted + mock parity</a:t>
+              <a:t>•  timeout/failure mapping</a:t>
             </a:r>
           </a:p>
         </p:txBody>
@@ -42283,7 +42025,7 @@
                         </a:defRPr>
                       </a:pPr>
                       <a:r>
-                        <a:t>Contract</a:t>
+                        <a:t>API client</a:t>
                       </a:r>
                     </a:p>
                   </a:txBody>
@@ -42331,7 +42073,7 @@
                         </a:defRPr>
                       </a:pPr>
                       <a:r>
-                        <a:t>Swagger/REST capture</a:t>
+                        <a:t>test + REST capture</a:t>
                       </a:r>
                     </a:p>
                   </a:txBody>
@@ -42975,7 +42717,7 @@
                 </a:solidFill>
                 <a:latin typeface="Aptos Display"/>
               </a:rPr>
-              <a:t>Handover backend ↔ Flutter</a:t>
+              <a:t>Flutter integration checklist</a:t>
             </a:r>
           </a:p>
         </p:txBody>
@@ -43262,7 +43004,7 @@
                 </a:solidFill>
                 <a:latin typeface="Aptos"/>
               </a:rPr>
-              <a:t>BE</a:t>
+              <a:t>CF</a:t>
             </a:r>
           </a:p>
         </p:txBody>
@@ -43301,7 +43043,7 @@
                 </a:solidFill>
                 <a:latin typeface="Aptos"/>
               </a:rPr>
-              <a:t>Backend menyediakan</a:t>
+              <a:t>Configuration</a:t>
             </a:r>
           </a:p>
         </p:txBody>
@@ -43343,7 +43085,7 @@
               <a:rPr>
                 <a:latin typeface="Aptos"/>
               </a:rPr>
-              <a:t>•  Base URL HTTPS</a:t>
+              <a:t>•  Base URL via dart-define</a:t>
             </a:r>
           </a:p>
           <a:p>
@@ -43362,7 +43104,7 @@
               <a:rPr>
                 <a:latin typeface="Aptos"/>
               </a:rPr>
-              <a:t>•  Swagger/OpenAPI</a:t>
+              <a:t>•  HTTPS untuk release</a:t>
             </a:r>
           </a:p>
           <a:p>
@@ -43381,7 +43123,7 @@
               <a:rPr>
                 <a:latin typeface="Aptos"/>
               </a:rPr>
-              <a:t>•  Demo credential</a:t>
+              <a:t>•  Timeout terpusat</a:t>
             </a:r>
           </a:p>
           <a:p>
@@ -43400,7 +43142,7 @@
               <a:rPr>
                 <a:latin typeface="Aptos"/>
               </a:rPr>
-              <a:t>•  Image/tag Docker</a:t>
+              <a:t>•  No hard-coded secret</a:t>
             </a:r>
           </a:p>
           <a:p>
@@ -43419,7 +43161,7 @@
               <a:rPr>
                 <a:latin typeface="Aptos"/>
               </a:rPr>
-              <a:t>•  Fault mode / test data</a:t>
+              <a:t>•  Debug cleartext terbatas</a:t>
             </a:r>
           </a:p>
           <a:p>
@@ -43438,7 +43180,7 @@
               <a:rPr>
                 <a:latin typeface="Aptos"/>
               </a:rPr>
-              <a:t>•  CORS/routing bila relevan</a:t>
+              <a:t>•  Environment terlihat</a:t>
             </a:r>
           </a:p>
         </p:txBody>
@@ -43608,7 +43350,7 @@
                 </a:solidFill>
                 <a:latin typeface="Aptos"/>
               </a:rPr>
-              <a:t>FE</a:t>
+              <a:t>FL</a:t>
             </a:r>
           </a:p>
         </p:txBody>
@@ -43647,7 +43389,7 @@
                 </a:solidFill>
                 <a:latin typeface="Aptos"/>
               </a:rPr>
-              <a:t>Flutter menyediakan</a:t>
+              <a:t>Implementation</a:t>
             </a:r>
           </a:p>
         </p:txBody>
@@ -43689,7 +43431,7 @@
               <a:rPr>
                 <a:latin typeface="Aptos"/>
               </a:rPr>
-              <a:t>•  Client version</a:t>
+              <a:t>•  Model/DTO bertipe</a:t>
             </a:r>
           </a:p>
           <a:p>
@@ -43708,7 +43450,7 @@
               <a:rPr>
                 <a:latin typeface="Aptos"/>
               </a:rPr>
-              <a:t>•  Environment target</a:t>
+              <a:t>•  ApiClient fokus transport</a:t>
             </a:r>
           </a:p>
           <a:p>
@@ -43727,7 +43469,7 @@
               <a:rPr>
                 <a:latin typeface="Aptos"/>
               </a:rPr>
-              <a:t>•  Request ID/error ID</a:t>
+              <a:t>•  Repository memilih source</a:t>
             </a:r>
           </a:p>
           <a:p>
@@ -43746,7 +43488,7 @@
               <a:rPr>
                 <a:latin typeface="Aptos"/>
               </a:rPr>
-              <a:t>•  Expected schema</a:t>
+              <a:t>•  Controller memiliki state</a:t>
             </a:r>
           </a:p>
           <a:p>
@@ -43765,7 +43507,7 @@
               <a:rPr>
                 <a:latin typeface="Aptos"/>
               </a:rPr>
-              <a:t>•  Repro steps</a:t>
+              <a:t>•  UI hanya render/intent</a:t>
             </a:r>
           </a:p>
           <a:p>
@@ -43784,7 +43526,7 @@
               <a:rPr>
                 <a:latin typeface="Aptos"/>
               </a:rPr>
-              <a:t>•  No secret in evidence</a:t>
+              <a:t>•  Lifecycle ditutup</a:t>
             </a:r>
           </a:p>
         </p:txBody>
@@ -43954,7 +43696,7 @@
                 </a:solidFill>
                 <a:latin typeface="Aptos"/>
               </a:rPr>
-              <a:t>↔</a:t>
+              <a:t>✓</a:t>
             </a:r>
           </a:p>
         </p:txBody>
@@ -43993,7 +43735,7 @@
                 </a:solidFill>
                 <a:latin typeface="Aptos"/>
               </a:rPr>
-              <a:t>Disepakati</a:t>
+              <a:t>Evidence</a:t>
             </a:r>
           </a:p>
         </p:txBody>
@@ -44035,7 +43777,7 @@
               <a:rPr>
                 <a:latin typeface="Aptos"/>
               </a:rPr>
-              <a:t>•  Contract version</a:t>
+              <a:t>•  Test parser/state</a:t>
             </a:r>
           </a:p>
           <a:p>
@@ -44054,7 +43796,7 @@
               <a:rPr>
                 <a:latin typeface="Aptos"/>
               </a:rPr>
-              <a:t>•  Breaking-change policy</a:t>
+              <a:t>•  GET/POST berhasil</a:t>
             </a:r>
           </a:p>
           <a:p>
@@ -44073,7 +43815,7 @@
               <a:rPr>
                 <a:latin typeface="Aptos"/>
               </a:rPr>
-              <a:t>•  Ownership incident</a:t>
+              <a:t>•  401/422 dipetakan</a:t>
             </a:r>
           </a:p>
           <a:p>
@@ -44092,7 +43834,7 @@
               <a:rPr>
                 <a:latin typeface="Aptos"/>
               </a:rPr>
-              <a:t>•  Training uptime window</a:t>
+              <a:t>•  Offline/cache jelas</a:t>
             </a:r>
           </a:p>
           <a:p>
@@ -44111,7 +43853,7 @@
               <a:rPr>
                 <a:latin typeface="Aptos"/>
               </a:rPr>
-              <a:t>•  Fallback mock</a:t>
+              <a:t>•  Request ID tanpa token</a:t>
             </a:r>
           </a:p>
           <a:p>
@@ -44130,7 +43872,7 @@
               <a:rPr>
                 <a:latin typeface="Aptos"/>
               </a:rPr>
-              <a:t>•  Data retention</a:t>
+              <a:t>•  README dapat diikuti</a:t>
             </a:r>
           </a:p>
         </p:txBody>
@@ -44169,7 +43911,7 @@
                 </a:solidFill>
                 <a:latin typeface="Aptos"/>
               </a:rPr>
-              <a:t>Satu halaman handoff mencegah jam debugging lintas tim.</a:t>
+              <a:t>Review berpusat pada kualitas implementasi Flutter.</a:t>
             </a:r>
           </a:p>
         </p:txBody>
@@ -45140,7 +44882,7 @@
                 </a:solidFill>
                 <a:latin typeface="Aptos"/>
               </a:rPr>
-              <a:t>Apa bukti Swagger dan implementasi server konsisten?</a:t>
+              <a:t>Apa bukti model Dart sesuai response API?</a:t>
             </a:r>
           </a:p>
         </p:txBody>
@@ -46990,7 +46732,7 @@
               <a:rPr>
                 <a:latin typeface="Aptos"/>
               </a:rPr>
-              <a:t>•  OpenAPI Specification</a:t>
+              <a:t>•  Dart JSON serialization</a:t>
             </a:r>
           </a:p>
           <a:p>
@@ -47298,7 +47040,7 @@
               <a:rPr>
                 <a:latin typeface="Aptos"/>
               </a:rPr>
-              <a:t>•  Generated API client dari OpenAPI</a:t>
+              <a:t>•  Code generation model/DTO</a:t>
             </a:r>
           </a:p>
           <a:p>
@@ -47355,7 +47097,7 @@
               <a:rPr>
                 <a:latin typeface="Aptos"/>
               </a:rPr>
-              <a:t>•  Observability SDK</a:t>
+              <a:t>•  Observability Flutter</a:t>
             </a:r>
           </a:p>
           <a:p>
@@ -47374,7 +47116,7 @@
               <a:rPr>
                 <a:latin typeface="Aptos"/>
               </a:rPr>
-              <a:t>•  Contract test di CI</a:t>
+              <a:t>•  Integration test di CI</a:t>
             </a:r>
           </a:p>
           <a:p>
@@ -50257,7 +49999,7 @@
                 </a:solidFill>
                 <a:latin typeface="Aptos"/>
               </a:rPr>
-              <a:t>Jika transport berubah dari mock ke Docker-hosted Express, View tidak ikut berubah.</a:t>
+              <a:t>Jika host atau implementasi API berubah, View tidak ikut berubah.</a:t>
             </a:r>
           </a:p>
         </p:txBody>

</xml_diff>